<commit_message>
chore(ppt): update InsurAI presentation file
</commit_message>
<xml_diff>
--- a/PPT/InsurAI.pptx
+++ b/PPT/InsurAI.pptx
@@ -5,7 +5,7 @@
     <p:sldMasterId id="2147483648" r:id="rId1"/>
   </p:sldMasterIdLst>
   <p:notesMasterIdLst>
-    <p:notesMasterId r:id="rId7"/>
+    <p:notesMasterId r:id="rId8"/>
   </p:notesMasterIdLst>
   <p:sldIdLst>
     <p:sldId id="256" r:id="rId2"/>
@@ -13,13 +13,15 @@
     <p:sldId id="258" r:id="rId4"/>
     <p:sldId id="259" r:id="rId5"/>
     <p:sldId id="260" r:id="rId6"/>
+    <p:sldId id="261" r:id="rId7"/>
   </p:sldIdLst>
   <p:sldSz cx="14630400" cy="8229600"/>
   <p:notesSz cx="8229600" cy="14630400"/>
   <p:embeddedFontLst>
     <p:embeddedFont>
-      <p:font typeface="Gelasio Semi Bold" panose="020B0604020202020204" charset="0"/>
-      <p:regular r:id="rId8"/>
+      <p:font typeface="Gelasio Semi Bold" pitchFamily="2" charset="77"/>
+      <p:regular r:id="rId9"/>
+      <p:bold r:id="rId10"/>
     </p:embeddedFont>
   </p:embeddedFontLst>
   <p:defaultTextStyle>
@@ -2005,6 +2007,55 @@
           </a:p>
         </p:txBody>
       </p:sp>
+      <p:sp>
+        <p:nvSpPr>
+          <p:cNvPr id="4" name="TextBox 3">
+            <a:extLst>
+              <a:ext uri="{FF2B5EF4-FFF2-40B4-BE49-F238E27FC236}">
+                <a16:creationId xmlns:a16="http://schemas.microsoft.com/office/drawing/2014/main" id="{ADCD2C82-CE3A-9A23-4749-B2C53FBDDE57}"/>
+              </a:ext>
+            </a:extLst>
+          </p:cNvPr>
+          <p:cNvSpPr txBox="1"/>
+          <p:nvPr/>
+        </p:nvSpPr>
+        <p:spPr>
+          <a:xfrm>
+            <a:off x="9353862" y="6183734"/>
+            <a:ext cx="4809330" cy="1754326"/>
+          </a:xfrm>
+          <a:prstGeom prst="rect">
+            <a:avLst/>
+          </a:prstGeom>
+          <a:noFill/>
+        </p:spPr>
+        <p:txBody>
+          <a:bodyPr wrap="none" rtlCol="0">
+            <a:spAutoFit/>
+          </a:bodyPr>
+          <a:lstStyle/>
+          <a:p>
+            <a:r>
+              <a:rPr lang="en-US" sz="3600" b="1" dirty="0"/>
+              <a:t>PRESENTED BY: TEAM B</a:t>
+            </a:r>
+            <a:br>
+              <a:rPr lang="en-US" sz="3600" b="1" dirty="0"/>
+            </a:br>
+            <a:r>
+              <a:rPr lang="en-US" sz="3600" b="1" dirty="0"/>
+              <a:t>1. NISHANT KUMAR</a:t>
+            </a:r>
+            <a:br>
+              <a:rPr lang="en-US" sz="3600" b="1" dirty="0"/>
+            </a:br>
+            <a:r>
+              <a:rPr lang="en-US" sz="3600" b="1" dirty="0"/>
+              <a:t>2. SUSHIL</a:t>
+            </a:r>
+          </a:p>
+        </p:txBody>
+      </p:sp>
     </p:spTree>
   </p:cSld>
   <p:clrMapOvr>
@@ -2724,6 +2775,101 @@
     <p:extLst>
       <p:ext uri="{BB962C8B-B14F-4D97-AF65-F5344CB8AC3E}">
         <p14:creationId xmlns:p14="http://schemas.microsoft.com/office/powerpoint/2010/main" val="3610542879"/>
+      </p:ext>
+    </p:extLst>
+  </p:cSld>
+  <p:clrMapOvr>
+    <a:masterClrMapping/>
+  </p:clrMapOvr>
+</p:sld>
+</file>
+
+<file path=ppt/slides/slide6.xml><?xml version="1.0" encoding="utf-8"?>
+<p:sld xmlns:a="http://schemas.openxmlformats.org/drawingml/2006/main" xmlns:r="http://schemas.openxmlformats.org/officeDocument/2006/relationships" xmlns:p="http://schemas.openxmlformats.org/presentationml/2006/main">
+  <p:cSld>
+    <p:spTree>
+      <p:nvGrpSpPr>
+        <p:cNvPr id="1" name=""/>
+        <p:cNvGrpSpPr/>
+        <p:nvPr/>
+      </p:nvGrpSpPr>
+      <p:grpSpPr>
+        <a:xfrm>
+          <a:off x="0" y="0"/>
+          <a:ext cx="0" cy="0"/>
+          <a:chOff x="0" y="0"/>
+          <a:chExt cx="0" cy="0"/>
+        </a:xfrm>
+      </p:grpSpPr>
+      <p:sp>
+        <p:nvSpPr>
+          <p:cNvPr id="2" name="TextBox 1">
+            <a:extLst>
+              <a:ext uri="{FF2B5EF4-FFF2-40B4-BE49-F238E27FC236}">
+                <a16:creationId xmlns:a16="http://schemas.microsoft.com/office/drawing/2014/main" id="{19C0FD93-7DC4-EB76-421B-C61C45F5C923}"/>
+              </a:ext>
+            </a:extLst>
+          </p:cNvPr>
+          <p:cNvSpPr txBox="1"/>
+          <p:nvPr/>
+        </p:nvSpPr>
+        <p:spPr>
+          <a:xfrm>
+            <a:off x="4161035" y="2908093"/>
+            <a:ext cx="6308330" cy="1569660"/>
+          </a:xfrm>
+          <a:prstGeom prst="rect">
+            <a:avLst/>
+          </a:prstGeom>
+          <a:noFill/>
+        </p:spPr>
+        <p:txBody>
+          <a:bodyPr wrap="none" rtlCol="0">
+            <a:spAutoFit/>
+          </a:bodyPr>
+          <a:lstStyle/>
+          <a:p>
+            <a:r>
+              <a:rPr lang="en-US" sz="9600" b="1" dirty="0"/>
+              <a:t>THANK YOU</a:t>
+            </a:r>
+          </a:p>
+        </p:txBody>
+      </p:sp>
+      <p:pic>
+        <p:nvPicPr>
+          <p:cNvPr id="5" name="Picture 4">
+            <a:extLst>
+              <a:ext uri="{FF2B5EF4-FFF2-40B4-BE49-F238E27FC236}">
+                <a16:creationId xmlns:a16="http://schemas.microsoft.com/office/drawing/2014/main" id="{2ACC908E-3AFD-1DE0-5C03-782DBB9C0314}"/>
+              </a:ext>
+            </a:extLst>
+          </p:cNvPr>
+          <p:cNvPicPr>
+            <a:picLocks noChangeAspect="1"/>
+          </p:cNvPicPr>
+          <p:nvPr/>
+        </p:nvPicPr>
+        <p:blipFill>
+          <a:blip r:embed="rId2"/>
+          <a:stretch>
+            <a:fillRect/>
+          </a:stretch>
+        </p:blipFill>
+        <p:spPr>
+          <a:xfrm>
+            <a:off x="11391900" y="7574301"/>
+            <a:ext cx="3238500" cy="546100"/>
+          </a:xfrm>
+          <a:prstGeom prst="rect">
+            <a:avLst/>
+          </a:prstGeom>
+        </p:spPr>
+      </p:pic>
+    </p:spTree>
+    <p:extLst>
+      <p:ext uri="{BB962C8B-B14F-4D97-AF65-F5344CB8AC3E}">
+        <p14:creationId xmlns:p14="http://schemas.microsoft.com/office/powerpoint/2010/main" val="392127077"/>
       </p:ext>
     </p:extLst>
   </p:cSld>

</xml_diff>